<commit_message>
Fix slide 6 layout: center text in the DATOS/INFORMACIÓN boxes
The two concept boxes had one paragraph with an embedded line break and a stray
second pPr, so the sub-labels drifted and "DATOS" had low contrast. Split into two
properly centered paragraphs and darkened the DATOS label for readability.

Co-Authored-By: Claude Opus 4.8 <noreply@anthropic.com>
</commit_message>
<xml_diff>
--- a/defensa/Presentacion_Android_Market.pptx
+++ b/defensa/Presentacion_Android_Market.pptx
@@ -13347,12 +13347,13 @@
             <a:r>
               <a:rPr lang="en-US" sz="1300" b="1" dirty="0">
                 <a:solidFill>
-                  <a:srgbClr val="6B7884"/>
-                </a:solidFill>
-              </a:rPr>
-              <a:t>DATOS
-</a:t>
-            </a:r>
+                  <a:srgbClr val="1F2D3D"/>
+                </a:solidFill>
+              </a:rPr>
+              <a:t>DATOS</a:t>
+            </a:r>
+          </a:p>
+          <a:p>
             <a:pPr algn="ctr" indent="0" marL="0">
               <a:buNone/>
             </a:pPr>
@@ -13456,9 +13457,10 @@
                   <a:srgbClr val="FFFFFF"/>
                 </a:solidFill>
               </a:rPr>
-              <a:t>INFORMACIÓN
-</a:t>
-            </a:r>
+              <a:t>INFORMACIÓN</a:t>
+            </a:r>
+          </a:p>
+          <a:p>
             <a:pPr algn="ctr" indent="0" marL="0">
               <a:buNone/>
             </a:pPr>

</xml_diff>

<commit_message>
Add real-shop photo evidence: new "Evidencia fotográfica" slide + photos
defensa/Presentacion_Android_Market.pptx gains an annex slide ("Android Market —
un caso real") with a 3x2 grid of real photos of the shop, the street in
Rurrenabaque, repairs in progress, dismantled phones and spare parts. The 9 source
photos are stored under defensa/fotos/.

Co-Authored-By: Claude Opus 4.8 <noreply@anthropic.com>
</commit_message>
<xml_diff>
--- a/defensa/Presentacion_Android_Market.pptx
+++ b/defensa/Presentacion_Android_Market.pptx
@@ -20,6 +20,7 @@
     <p:sldId id="268" r:id="rId14"/>
     <p:sldId id="269" r:id="rId15"/>
     <p:sldId id="270" r:id="rId16"/>
+    <p:sldId id="271" r:id="rId22"/>
   </p:sldIdLst>
   <p:notesMasterIdLst>
     <p:notesMasterId r:id="rId17"/>
@@ -9459,6 +9460,483 @@
 </p:sld>
 </file>
 
+<file path=ppt/slides/slide16.xml><?xml version="1.0" encoding="utf-8"?>
+<p:sld xmlns:a="http://schemas.openxmlformats.org/drawingml/2006/main" xmlns:p="http://schemas.openxmlformats.org/presentationml/2006/main" xmlns:r="http://schemas.openxmlformats.org/officeDocument/2006/relationships">
+  <p:cSld>
+    <p:spTree>
+      <p:nvGrpSpPr>
+        <p:cNvPr id="1" name=""/>
+        <p:cNvGrpSpPr/>
+        <p:nvPr/>
+      </p:nvGrpSpPr>
+      <p:grpSpPr/>
+      <p:sp>
+        <p:nvSpPr>
+          <p:cNvPr id="2" name="TextBox 1"/>
+          <p:cNvSpPr txBox="1"/>
+          <p:nvPr/>
+        </p:nvSpPr>
+        <p:spPr>
+          <a:xfrm>
+            <a:off x="640080" y="502920"/>
+            <a:ext cx="10881360" cy="292608"/>
+          </a:xfrm>
+          <a:prstGeom prst="rect">
+            <a:avLst/>
+          </a:prstGeom>
+          <a:noFill/>
+        </p:spPr>
+        <p:txBody>
+          <a:bodyPr wrap="square" lIns="0" rIns="0" tIns="0" bIns="0" anchor="t">
+            <a:spAutoFit/>
+          </a:bodyPr>
+          <a:lstStyle/>
+          <a:p>
+            <a:pPr algn="l"/>
+            <a:r>
+              <a:rPr sz="1250" b="1">
+                <a:solidFill>
+                  <a:srgbClr val="11795C"/>
+                </a:solidFill>
+                <a:latin typeface="Calibri"/>
+              </a:rPr>
+              <a:t>ANEXOS · EVIDENCIA FOTOGRÁFICA</a:t>
+            </a:r>
+          </a:p>
+        </p:txBody>
+      </p:sp>
+      <p:sp>
+        <p:nvSpPr>
+          <p:cNvPr id="3" name="TextBox 2"/>
+          <p:cNvSpPr txBox="1"/>
+          <p:nvPr/>
+        </p:nvSpPr>
+        <p:spPr>
+          <a:xfrm>
+            <a:off x="640080" y="804672"/>
+            <a:ext cx="10881360" cy="777240"/>
+          </a:xfrm>
+          <a:prstGeom prst="rect">
+            <a:avLst/>
+          </a:prstGeom>
+          <a:noFill/>
+        </p:spPr>
+        <p:txBody>
+          <a:bodyPr wrap="square" lIns="0" rIns="0" tIns="0" bIns="0" anchor="t">
+            <a:spAutoFit/>
+          </a:bodyPr>
+          <a:lstStyle/>
+          <a:p>
+            <a:pPr algn="l"/>
+            <a:r>
+              <a:rPr sz="3100" b="1">
+                <a:solidFill>
+                  <a:srgbClr val="1F2D3D"/>
+                </a:solidFill>
+                <a:latin typeface="Cambria"/>
+              </a:rPr>
+              <a:t>Android Market — un caso real</a:t>
+            </a:r>
+          </a:p>
+        </p:txBody>
+      </p:sp>
+      <p:pic>
+        <p:nvPicPr>
+          <p:cNvPr id="4" name="Picture 3" descr="g1.jpg"/>
+          <p:cNvPicPr>
+            <a:picLocks noChangeAspect="1"/>
+          </p:cNvPicPr>
+          <p:nvPr/>
+        </p:nvPicPr>
+        <p:blipFill>
+          <a:blip r:embed="rId2"/>
+          <a:stretch>
+            <a:fillRect/>
+          </a:stretch>
+        </p:blipFill>
+        <p:spPr>
+          <a:xfrm>
+            <a:off x="640080" y="1554480"/>
+            <a:ext cx="3291840" cy="2194560"/>
+          </a:xfrm>
+          <a:prstGeom prst="rect">
+            <a:avLst/>
+          </a:prstGeom>
+        </p:spPr>
+      </p:pic>
+      <p:sp>
+        <p:nvSpPr>
+          <p:cNvPr id="5" name="TextBox 4"/>
+          <p:cNvSpPr txBox="1"/>
+          <p:nvPr/>
+        </p:nvSpPr>
+        <p:spPr>
+          <a:xfrm>
+            <a:off x="640080" y="3767327"/>
+            <a:ext cx="3291840" cy="228600"/>
+          </a:xfrm>
+          <a:prstGeom prst="rect">
+            <a:avLst/>
+          </a:prstGeom>
+          <a:noFill/>
+        </p:spPr>
+        <p:txBody>
+          <a:bodyPr wrap="square" lIns="0" rIns="0" tIns="0" bIns="0" anchor="t">
+            <a:spAutoFit/>
+          </a:bodyPr>
+          <a:lstStyle/>
+          <a:p>
+            <a:pPr algn="ctr"/>
+            <a:r>
+              <a:rPr sz="1050" b="0">
+                <a:solidFill>
+                  <a:srgbClr val="667085"/>
+                </a:solidFill>
+                <a:latin typeface="Calibri"/>
+              </a:rPr>
+              <a:t>El local — Android Market</a:t>
+            </a:r>
+          </a:p>
+        </p:txBody>
+      </p:sp>
+      <p:pic>
+        <p:nvPicPr>
+          <p:cNvPr id="6" name="Picture 5" descr="g2.jpg"/>
+          <p:cNvPicPr>
+            <a:picLocks noChangeAspect="1"/>
+          </p:cNvPicPr>
+          <p:nvPr/>
+        </p:nvPicPr>
+        <p:blipFill>
+          <a:blip r:embed="rId3"/>
+          <a:stretch>
+            <a:fillRect/>
+          </a:stretch>
+        </p:blipFill>
+        <p:spPr>
+          <a:xfrm>
+            <a:off x="4449470" y="1554480"/>
+            <a:ext cx="3291840" cy="2194560"/>
+          </a:xfrm>
+          <a:prstGeom prst="rect">
+            <a:avLst/>
+          </a:prstGeom>
+        </p:spPr>
+      </p:pic>
+      <p:sp>
+        <p:nvSpPr>
+          <p:cNvPr id="7" name="TextBox 6"/>
+          <p:cNvSpPr txBox="1"/>
+          <p:nvPr/>
+        </p:nvSpPr>
+        <p:spPr>
+          <a:xfrm>
+            <a:off x="4449470" y="3767327"/>
+            <a:ext cx="3291840" cy="228600"/>
+          </a:xfrm>
+          <a:prstGeom prst="rect">
+            <a:avLst/>
+          </a:prstGeom>
+          <a:noFill/>
+        </p:spPr>
+        <p:txBody>
+          <a:bodyPr wrap="square" lIns="0" rIns="0" tIns="0" bIns="0" anchor="t">
+            <a:spAutoFit/>
+          </a:bodyPr>
+          <a:lstStyle/>
+          <a:p>
+            <a:pPr algn="ctr"/>
+            <a:r>
+              <a:rPr sz="1050" b="0">
+                <a:solidFill>
+                  <a:srgbClr val="667085"/>
+                </a:solidFill>
+                <a:latin typeface="Calibri"/>
+              </a:rPr>
+              <a:t>Atención al cliente</a:t>
+            </a:r>
+          </a:p>
+        </p:txBody>
+      </p:sp>
+      <p:pic>
+        <p:nvPicPr>
+          <p:cNvPr id="8" name="Picture 7" descr="g3.jpg"/>
+          <p:cNvPicPr>
+            <a:picLocks noChangeAspect="1"/>
+          </p:cNvPicPr>
+          <p:nvPr/>
+        </p:nvPicPr>
+        <p:blipFill>
+          <a:blip r:embed="rId4"/>
+          <a:stretch>
+            <a:fillRect/>
+          </a:stretch>
+        </p:blipFill>
+        <p:spPr>
+          <a:xfrm>
+            <a:off x="8258860" y="1554480"/>
+            <a:ext cx="3291840" cy="2194560"/>
+          </a:xfrm>
+          <a:prstGeom prst="rect">
+            <a:avLst/>
+          </a:prstGeom>
+        </p:spPr>
+      </p:pic>
+      <p:sp>
+        <p:nvSpPr>
+          <p:cNvPr id="9" name="TextBox 8"/>
+          <p:cNvSpPr txBox="1"/>
+          <p:nvPr/>
+        </p:nvSpPr>
+        <p:spPr>
+          <a:xfrm>
+            <a:off x="8258860" y="3767327"/>
+            <a:ext cx="3291840" cy="228600"/>
+          </a:xfrm>
+          <a:prstGeom prst="rect">
+            <a:avLst/>
+          </a:prstGeom>
+          <a:noFill/>
+        </p:spPr>
+        <p:txBody>
+          <a:bodyPr wrap="square" lIns="0" rIns="0" tIns="0" bIns="0" anchor="t">
+            <a:spAutoFit/>
+          </a:bodyPr>
+          <a:lstStyle/>
+          <a:p>
+            <a:pPr algn="ctr"/>
+            <a:r>
+              <a:rPr sz="1050" b="0">
+                <a:solidFill>
+                  <a:srgbClr val="667085"/>
+                </a:solidFill>
+                <a:latin typeface="Calibri"/>
+              </a:rPr>
+              <a:t>Rurrenabaque, Beni</a:t>
+            </a:r>
+          </a:p>
+        </p:txBody>
+      </p:sp>
+      <p:pic>
+        <p:nvPicPr>
+          <p:cNvPr id="10" name="Picture 9" descr="g4.jpg"/>
+          <p:cNvPicPr>
+            <a:picLocks noChangeAspect="1"/>
+          </p:cNvPicPr>
+          <p:nvPr/>
+        </p:nvPicPr>
+        <p:blipFill>
+          <a:blip r:embed="rId5"/>
+          <a:stretch>
+            <a:fillRect/>
+          </a:stretch>
+        </p:blipFill>
+        <p:spPr>
+          <a:xfrm>
+            <a:off x="640080" y="4114800"/>
+            <a:ext cx="3291840" cy="2194560"/>
+          </a:xfrm>
+          <a:prstGeom prst="rect">
+            <a:avLst/>
+          </a:prstGeom>
+        </p:spPr>
+      </p:pic>
+      <p:sp>
+        <p:nvSpPr>
+          <p:cNvPr id="11" name="TextBox 10"/>
+          <p:cNvSpPr txBox="1"/>
+          <p:nvPr/>
+        </p:nvSpPr>
+        <p:spPr>
+          <a:xfrm>
+            <a:off x="640080" y="6327648"/>
+            <a:ext cx="3291840" cy="228600"/>
+          </a:xfrm>
+          <a:prstGeom prst="rect">
+            <a:avLst/>
+          </a:prstGeom>
+          <a:noFill/>
+        </p:spPr>
+        <p:txBody>
+          <a:bodyPr wrap="square" lIns="0" rIns="0" tIns="0" bIns="0" anchor="t">
+            <a:spAutoFit/>
+          </a:bodyPr>
+          <a:lstStyle/>
+          <a:p>
+            <a:pPr algn="ctr"/>
+            <a:r>
+              <a:rPr sz="1050" b="0">
+                <a:solidFill>
+                  <a:srgbClr val="667085"/>
+                </a:solidFill>
+                <a:latin typeface="Calibri"/>
+              </a:rPr>
+              <a:t>Diagnóstico y reparación</a:t>
+            </a:r>
+          </a:p>
+        </p:txBody>
+      </p:sp>
+      <p:pic>
+        <p:nvPicPr>
+          <p:cNvPr id="12" name="Picture 11" descr="g5.jpg"/>
+          <p:cNvPicPr>
+            <a:picLocks noChangeAspect="1"/>
+          </p:cNvPicPr>
+          <p:nvPr/>
+        </p:nvPicPr>
+        <p:blipFill>
+          <a:blip r:embed="rId6"/>
+          <a:stretch>
+            <a:fillRect/>
+          </a:stretch>
+        </p:blipFill>
+        <p:spPr>
+          <a:xfrm>
+            <a:off x="4449470" y="4114800"/>
+            <a:ext cx="3291840" cy="2194560"/>
+          </a:xfrm>
+          <a:prstGeom prst="rect">
+            <a:avLst/>
+          </a:prstGeom>
+        </p:spPr>
+      </p:pic>
+      <p:sp>
+        <p:nvSpPr>
+          <p:cNvPr id="13" name="TextBox 12"/>
+          <p:cNvSpPr txBox="1"/>
+          <p:nvPr/>
+        </p:nvSpPr>
+        <p:spPr>
+          <a:xfrm>
+            <a:off x="4449470" y="6327648"/>
+            <a:ext cx="3291840" cy="228600"/>
+          </a:xfrm>
+          <a:prstGeom prst="rect">
+            <a:avLst/>
+          </a:prstGeom>
+          <a:noFill/>
+        </p:spPr>
+        <p:txBody>
+          <a:bodyPr wrap="square" lIns="0" rIns="0" tIns="0" bIns="0" anchor="t">
+            <a:spAutoFit/>
+          </a:bodyPr>
+          <a:lstStyle/>
+          <a:p>
+            <a:pPr algn="ctr"/>
+            <a:r>
+              <a:rPr sz="1050" b="0">
+                <a:solidFill>
+                  <a:srgbClr val="667085"/>
+                </a:solidFill>
+                <a:latin typeface="Calibri"/>
+              </a:rPr>
+              <a:t>Equipos en reparación</a:t>
+            </a:r>
+          </a:p>
+        </p:txBody>
+      </p:sp>
+      <p:pic>
+        <p:nvPicPr>
+          <p:cNvPr id="14" name="Picture 13" descr="g6.jpg"/>
+          <p:cNvPicPr>
+            <a:picLocks noChangeAspect="1"/>
+          </p:cNvPicPr>
+          <p:nvPr/>
+        </p:nvPicPr>
+        <p:blipFill>
+          <a:blip r:embed="rId7"/>
+          <a:stretch>
+            <a:fillRect/>
+          </a:stretch>
+        </p:blipFill>
+        <p:spPr>
+          <a:xfrm>
+            <a:off x="8258860" y="4114800"/>
+            <a:ext cx="3291840" cy="2194560"/>
+          </a:xfrm>
+          <a:prstGeom prst="rect">
+            <a:avLst/>
+          </a:prstGeom>
+        </p:spPr>
+      </p:pic>
+      <p:sp>
+        <p:nvSpPr>
+          <p:cNvPr id="15" name="TextBox 14"/>
+          <p:cNvSpPr txBox="1"/>
+          <p:nvPr/>
+        </p:nvSpPr>
+        <p:spPr>
+          <a:xfrm>
+            <a:off x="8258860" y="6327648"/>
+            <a:ext cx="3291840" cy="228600"/>
+          </a:xfrm>
+          <a:prstGeom prst="rect">
+            <a:avLst/>
+          </a:prstGeom>
+          <a:noFill/>
+        </p:spPr>
+        <p:txBody>
+          <a:bodyPr wrap="square" lIns="0" rIns="0" tIns="0" bIns="0" anchor="t">
+            <a:spAutoFit/>
+          </a:bodyPr>
+          <a:lstStyle/>
+          <a:p>
+            <a:pPr algn="ctr"/>
+            <a:r>
+              <a:rPr sz="1050" b="0">
+                <a:solidFill>
+                  <a:srgbClr val="667085"/>
+                </a:solidFill>
+                <a:latin typeface="Calibri"/>
+              </a:rPr>
+              <a:t>Repuestos y baterías</a:t>
+            </a:r>
+          </a:p>
+        </p:txBody>
+      </p:sp>
+      <p:sp>
+        <p:nvSpPr>
+          <p:cNvPr id="16" name="TextBox 15"/>
+          <p:cNvSpPr txBox="1"/>
+          <p:nvPr/>
+        </p:nvSpPr>
+        <p:spPr>
+          <a:xfrm>
+            <a:off x="640080" y="6565392"/>
+            <a:ext cx="7315200" cy="274320"/>
+          </a:xfrm>
+          <a:prstGeom prst="rect">
+            <a:avLst/>
+          </a:prstGeom>
+          <a:noFill/>
+        </p:spPr>
+        <p:txBody>
+          <a:bodyPr wrap="square" lIns="0" rIns="0" tIns="0" bIns="0" anchor="t">
+            <a:spAutoFit/>
+          </a:bodyPr>
+          <a:lstStyle/>
+          <a:p>
+            <a:pPr algn="l"/>
+            <a:r>
+              <a:rPr sz="900" b="0">
+                <a:solidFill>
+                  <a:srgbClr val="667085"/>
+                </a:solidFill>
+                <a:latin typeface="Calibri"/>
+              </a:rPr>
+              <a:t>Android Market · Sistema de Información para Servicios Técnicos</a:t>
+            </a:r>
+          </a:p>
+        </p:txBody>
+      </p:sp>
+    </p:spTree>
+  </p:cSld>
+  <p:clrMapOvr>
+    <a:masterClrMapping/>
+  </p:clrMapOvr>
+</p:sld>
+</file>
+
 <file path=ppt/slides/slide2.xml><?xml version="1.0" encoding="utf-8"?>
 <p:sld xmlns:a="http://schemas.openxmlformats.org/drawingml/2006/main" xmlns:r="http://schemas.openxmlformats.org/officeDocument/2006/relationships" xmlns:p="http://schemas.openxmlformats.org/presentationml/2006/main">
   <p:cSld name="Slide 2">

</xml_diff>